<commit_message>
Rebuild the deck so it carries the team name
build.py was updated with TEAM_NAME = "Vagabonds" and never re-run, so the
submitted artefact was still the 11 Sep export and named neither the team nor
the project. The deck is what goes on the portal, so the one file nobody
rebuilt was the one file that is actually submitted.

Team ID and Theme stay as the amber guillemet placeholders; only the portal
can supply them. The .pdf and slide-*.jpg beside it are not produced by this
script and still need a PowerPoint export once those two fields are filled.
</commit_message>
<xml_diff>
--- a/deck/SIH26171_Idea_Submission.pptx
+++ b/deck/SIH26171_Idea_Submission.pptx
@@ -5924,12 +5924,12 @@
               <a:t>Team Name – </a:t>
             </a:r>
             <a:r>
-              <a:rPr sz="1300" b="1">
-                <a:solidFill>
-                  <a:srgbClr val="B46A00"/>
-                </a:solidFill>
-              </a:rPr>
-              <a:t>«Team Name»</a:t>
+              <a:rPr sz="1300" b="0">
+                <a:solidFill>
+                  <a:srgbClr val="141B2E"/>
+                </a:solidFill>
+              </a:rPr>
+              <a:t>Vagabonds</a:t>
             </a:r>
           </a:p>
         </p:txBody>
@@ -6213,7 +6213,7 @@
                   <a:srgbClr val="B46A00"/>
                 </a:solidFill>
               </a:rPr>
-              <a:t>«Team Name»</a:t>
+              <a:t>Vagabonds</a:t>
             </a:r>
           </a:p>
         </p:txBody>
@@ -6798,7 +6798,7 @@
                   <a:srgbClr val="B46A00"/>
                 </a:solidFill>
               </a:rPr>
-              <a:t>«Team Name»</a:t>
+              <a:t>Vagabonds</a:t>
             </a:r>
           </a:p>
         </p:txBody>
@@ -7494,7 +7494,7 @@
                   <a:srgbClr val="B46A00"/>
                 </a:solidFill>
               </a:rPr>
-              <a:t>«Team Name»</a:t>
+              <a:t>Vagabonds</a:t>
             </a:r>
           </a:p>
         </p:txBody>
@@ -8459,7 +8459,7 @@
                   <a:srgbClr val="B46A00"/>
                 </a:solidFill>
               </a:rPr>
-              <a:t>«Team Name»</a:t>
+              <a:t>Vagabonds</a:t>
             </a:r>
           </a:p>
         </p:txBody>
@@ -9319,7 +9319,7 @@
                   <a:srgbClr val="B46A00"/>
                 </a:solidFill>
               </a:rPr>
-              <a:t>«Team Name»</a:t>
+              <a:t>Vagabonds</a:t>
             </a:r>
           </a:p>
         </p:txBody>

</xml_diff>